<commit_message>
Housekeeping: sync archived pptx edits, ignore local settings
Ignore ~$* (Office lock files) and .claude/ (per-machine Claude Code
settings) so they stop showing up in git status. Also flush pending
edits to the two archived pptx decks.
</commit_message>
<xml_diff>
--- a/docs/slides/ppt-archive/class/technical/04-Protocols.pptx
+++ b/docs/slides/ppt-archive/class/technical/04-Protocols.pptx
@@ -242,7 +242,7 @@
           <a:p>
             <a:fld id="{CEDAEFA1-2302-CF41-B3D2-D7622FF3D015}" type="datetimeFigureOut">
               <a:rPr lang="en-US" smtClean="0"/>
-              <a:t>10/2/25</a:t>
+              <a:t>10/6/25</a:t>
             </a:fld>
             <a:endParaRPr lang="en-US"/>
           </a:p>
@@ -2050,14 +2050,14 @@
           <a:ln/>
           <a:extLst>
             <a:ext uri="{909E8E84-426E-40dd-AFC4-6F175D3DCCD1}">
-              <a14:hiddenFill xmlns="" xmlns:a14="http://schemas.microsoft.com/office/drawing/2010/main">
+              <a14:hiddenFill xmlns:a14="http://schemas.microsoft.com/office/drawing/2010/main" xmlns="">
                 <a:solidFill>
                   <a:srgbClr val="FFFFFF"/>
                 </a:solidFill>
               </a14:hiddenFill>
             </a:ext>
             <a:ext uri="{91240B29-F687-4f45-9708-019B960494DF}">
-              <a14:hiddenLine xmlns="" xmlns:a14="http://schemas.microsoft.com/office/drawing/2010/main" w="9525">
+              <a14:hiddenLine xmlns:a14="http://schemas.microsoft.com/office/drawing/2010/main" xmlns="" w="9525">
                 <a:solidFill>
                   <a:srgbClr val="000000"/>
                 </a:solidFill>
@@ -2067,7 +2067,7 @@
               </a14:hiddenLine>
             </a:ext>
             <a:ext uri="{FAA26D3D-D897-4be2-8F04-BA451C77F1D7}">
-              <ma14:placeholderFlag xmlns="" xmlns:ma14="http://schemas.microsoft.com/office/mac/drawingml/2011/main" val="1"/>
+              <ma14:placeholderFlag xmlns:ma14="http://schemas.microsoft.com/office/mac/drawingml/2011/main" xmlns="" val="1"/>
             </a:ext>
           </a:extLst>
         </p:spPr>
@@ -2094,14 +2094,14 @@
           <a:ln/>
           <a:extLst>
             <a:ext uri="{909E8E84-426E-40dd-AFC4-6F175D3DCCD1}">
-              <a14:hiddenFill xmlns="" xmlns:a14="http://schemas.microsoft.com/office/drawing/2010/main">
+              <a14:hiddenFill xmlns:a14="http://schemas.microsoft.com/office/drawing/2010/main" xmlns="">
                 <a:solidFill>
                   <a:srgbClr val="FFFFFF"/>
                 </a:solidFill>
               </a14:hiddenFill>
             </a:ext>
             <a:ext uri="{91240B29-F687-4f45-9708-019B960494DF}">
-              <a14:hiddenLine xmlns="" xmlns:a14="http://schemas.microsoft.com/office/drawing/2010/main" w="9525">
+              <a14:hiddenLine xmlns:a14="http://schemas.microsoft.com/office/drawing/2010/main" xmlns="" w="9525">
                 <a:solidFill>
                   <a:srgbClr val="000000"/>
                 </a:solidFill>
@@ -2294,14 +2294,14 @@
           <a:ln/>
           <a:extLst>
             <a:ext uri="{909E8E84-426E-40dd-AFC4-6F175D3DCCD1}">
-              <a14:hiddenFill xmlns="" xmlns:a14="http://schemas.microsoft.com/office/drawing/2010/main">
+              <a14:hiddenFill xmlns:a14="http://schemas.microsoft.com/office/drawing/2010/main" xmlns="">
                 <a:solidFill>
                   <a:srgbClr val="FFFFFF"/>
                 </a:solidFill>
               </a14:hiddenFill>
             </a:ext>
             <a:ext uri="{91240B29-F687-4f45-9708-019B960494DF}">
-              <a14:hiddenLine xmlns="" xmlns:a14="http://schemas.microsoft.com/office/drawing/2010/main" w="9525">
+              <a14:hiddenLine xmlns:a14="http://schemas.microsoft.com/office/drawing/2010/main" xmlns="" w="9525">
                 <a:solidFill>
                   <a:srgbClr val="000000"/>
                 </a:solidFill>
@@ -2311,7 +2311,7 @@
               </a14:hiddenLine>
             </a:ext>
             <a:ext uri="{FAA26D3D-D897-4be2-8F04-BA451C77F1D7}">
-              <ma14:placeholderFlag xmlns="" xmlns:ma14="http://schemas.microsoft.com/office/mac/drawingml/2011/main" val="1"/>
+              <ma14:placeholderFlag xmlns:ma14="http://schemas.microsoft.com/office/mac/drawingml/2011/main" xmlns="" val="1"/>
             </a:ext>
           </a:extLst>
         </p:spPr>
@@ -2338,14 +2338,14 @@
           <a:ln/>
           <a:extLst>
             <a:ext uri="{909E8E84-426E-40dd-AFC4-6F175D3DCCD1}">
-              <a14:hiddenFill xmlns="" xmlns:a14="http://schemas.microsoft.com/office/drawing/2010/main">
+              <a14:hiddenFill xmlns:a14="http://schemas.microsoft.com/office/drawing/2010/main" xmlns="">
                 <a:solidFill>
                   <a:srgbClr val="FFFFFF"/>
                 </a:solidFill>
               </a14:hiddenFill>
             </a:ext>
             <a:ext uri="{91240B29-F687-4f45-9708-019B960494DF}">
-              <a14:hiddenLine xmlns="" xmlns:a14="http://schemas.microsoft.com/office/drawing/2010/main" w="9525">
+              <a14:hiddenLine xmlns:a14="http://schemas.microsoft.com/office/drawing/2010/main" xmlns="" w="9525">
                 <a:solidFill>
                   <a:srgbClr val="000000"/>
                 </a:solidFill>
@@ -2538,14 +2538,14 @@
           <a:ln/>
           <a:extLst>
             <a:ext uri="{909E8E84-426E-40dd-AFC4-6F175D3DCCD1}">
-              <a14:hiddenFill xmlns="" xmlns:a14="http://schemas.microsoft.com/office/drawing/2010/main">
+              <a14:hiddenFill xmlns:a14="http://schemas.microsoft.com/office/drawing/2010/main" xmlns="">
                 <a:solidFill>
                   <a:srgbClr val="FFFFFF"/>
                 </a:solidFill>
               </a14:hiddenFill>
             </a:ext>
             <a:ext uri="{91240B29-F687-4f45-9708-019B960494DF}">
-              <a14:hiddenLine xmlns="" xmlns:a14="http://schemas.microsoft.com/office/drawing/2010/main" w="9525">
+              <a14:hiddenLine xmlns:a14="http://schemas.microsoft.com/office/drawing/2010/main" xmlns="" w="9525">
                 <a:solidFill>
                   <a:srgbClr val="000000"/>
                 </a:solidFill>
@@ -2555,7 +2555,7 @@
               </a14:hiddenLine>
             </a:ext>
             <a:ext uri="{FAA26D3D-D897-4be2-8F04-BA451C77F1D7}">
-              <ma14:placeholderFlag xmlns="" xmlns:ma14="http://schemas.microsoft.com/office/mac/drawingml/2011/main" val="1"/>
+              <ma14:placeholderFlag xmlns:ma14="http://schemas.microsoft.com/office/mac/drawingml/2011/main" xmlns="" val="1"/>
             </a:ext>
           </a:extLst>
         </p:spPr>
@@ -2582,14 +2582,14 @@
           <a:ln/>
           <a:extLst>
             <a:ext uri="{909E8E84-426E-40dd-AFC4-6F175D3DCCD1}">
-              <a14:hiddenFill xmlns="" xmlns:a14="http://schemas.microsoft.com/office/drawing/2010/main">
+              <a14:hiddenFill xmlns:a14="http://schemas.microsoft.com/office/drawing/2010/main" xmlns="">
                 <a:solidFill>
                   <a:srgbClr val="FFFFFF"/>
                 </a:solidFill>
               </a14:hiddenFill>
             </a:ext>
             <a:ext uri="{91240B29-F687-4f45-9708-019B960494DF}">
-              <a14:hiddenLine xmlns="" xmlns:a14="http://schemas.microsoft.com/office/drawing/2010/main" w="9525">
+              <a14:hiddenLine xmlns:a14="http://schemas.microsoft.com/office/drawing/2010/main" xmlns="" w="9525">
                 <a:solidFill>
                   <a:srgbClr val="000000"/>
                 </a:solidFill>
@@ -2796,7 +2796,7 @@
           <a:ln/>
           <a:extLst>
             <a:ext uri="{FAA26D3D-D897-4be2-8F04-BA451C77F1D7}">
-              <ma14:placeholderFlag xmlns="" xmlns:ma14="http://schemas.microsoft.com/office/mac/drawingml/2011/main" val="1"/>
+              <ma14:placeholderFlag xmlns:ma14="http://schemas.microsoft.com/office/mac/drawingml/2011/main" xmlns="" val="1"/>
             </a:ext>
           </a:extLst>
         </p:spPr>
@@ -2905,7 +2905,7 @@
           <a:ln/>
           <a:extLst>
             <a:ext uri="{FAA26D3D-D897-4be2-8F04-BA451C77F1D7}">
-              <ma14:placeholderFlag xmlns="" xmlns:ma14="http://schemas.microsoft.com/office/mac/drawingml/2011/main" val="1"/>
+              <ma14:placeholderFlag xmlns:ma14="http://schemas.microsoft.com/office/mac/drawingml/2011/main" xmlns="" val="1"/>
             </a:ext>
           </a:extLst>
         </p:spPr>
@@ -3038,7 +3038,7 @@
           <a:ln/>
           <a:extLst>
             <a:ext uri="{FAA26D3D-D897-4be2-8F04-BA451C77F1D7}">
-              <ma14:placeholderFlag xmlns="" xmlns:ma14="http://schemas.microsoft.com/office/mac/drawingml/2011/main" val="1"/>
+              <ma14:placeholderFlag xmlns:ma14="http://schemas.microsoft.com/office/mac/drawingml/2011/main" xmlns="" val="1"/>
             </a:ext>
           </a:extLst>
         </p:spPr>
@@ -3149,7 +3149,7 @@
           <a:ln/>
           <a:extLst>
             <a:ext uri="{FAA26D3D-D897-4be2-8F04-BA451C77F1D7}">
-              <ma14:placeholderFlag xmlns="" xmlns:ma14="http://schemas.microsoft.com/office/mac/drawingml/2011/main" val="1"/>
+              <ma14:placeholderFlag xmlns:ma14="http://schemas.microsoft.com/office/mac/drawingml/2011/main" xmlns="" val="1"/>
             </a:ext>
           </a:extLst>
         </p:spPr>
@@ -3498,7 +3498,7 @@
           <a:ln/>
           <a:extLst>
             <a:ext uri="{FAA26D3D-D897-4be2-8F04-BA451C77F1D7}">
-              <ma14:placeholderFlag xmlns:ma14="http://schemas.microsoft.com/office/mac/drawingml/2011/main" xmlns="" val="1"/>
+              <ma14:placeholderFlag xmlns="" xmlns:ma14="http://schemas.microsoft.com/office/mac/drawingml/2011/main" val="1"/>
             </a:ext>
           </a:extLst>
         </p:spPr>
@@ -4051,7 +4051,7 @@
           <a:p>
             <a:fld id="{C9E664E8-8019-2444-AEBA-CE692A70D4C8}" type="datetimeFigureOut">
               <a:rPr lang="en-US" smtClean="0"/>
-              <a:t>10/2/25</a:t>
+              <a:t>10/6/25</a:t>
             </a:fld>
             <a:endParaRPr lang="en-US"/>
           </a:p>
@@ -4249,7 +4249,7 @@
           <a:p>
             <a:fld id="{C9E664E8-8019-2444-AEBA-CE692A70D4C8}" type="datetimeFigureOut">
               <a:rPr lang="en-US" smtClean="0"/>
-              <a:t>10/2/25</a:t>
+              <a:t>10/6/25</a:t>
             </a:fld>
             <a:endParaRPr lang="en-US"/>
           </a:p>
@@ -4457,7 +4457,7 @@
           <a:p>
             <a:fld id="{C9E664E8-8019-2444-AEBA-CE692A70D4C8}" type="datetimeFigureOut">
               <a:rPr lang="en-US" smtClean="0"/>
-              <a:t>10/2/25</a:t>
+              <a:t>10/6/25</a:t>
             </a:fld>
             <a:endParaRPr lang="en-US"/>
           </a:p>
@@ -5143,7 +5143,7 @@
           <a:p>
             <a:fld id="{C9E664E8-8019-2444-AEBA-CE692A70D4C8}" type="datetimeFigureOut">
               <a:rPr lang="en-US" smtClean="0"/>
-              <a:t>10/2/25</a:t>
+              <a:t>10/6/25</a:t>
             </a:fld>
             <a:endParaRPr lang="en-US"/>
           </a:p>
@@ -5418,7 +5418,7 @@
           <a:p>
             <a:fld id="{C9E664E8-8019-2444-AEBA-CE692A70D4C8}" type="datetimeFigureOut">
               <a:rPr lang="en-US" smtClean="0"/>
-              <a:t>10/2/25</a:t>
+              <a:t>10/6/25</a:t>
             </a:fld>
             <a:endParaRPr lang="en-US"/>
           </a:p>
@@ -5683,7 +5683,7 @@
           <a:p>
             <a:fld id="{C9E664E8-8019-2444-AEBA-CE692A70D4C8}" type="datetimeFigureOut">
               <a:rPr lang="en-US" smtClean="0"/>
-              <a:t>10/2/25</a:t>
+              <a:t>10/6/25</a:t>
             </a:fld>
             <a:endParaRPr lang="en-US"/>
           </a:p>
@@ -6095,7 +6095,7 @@
           <a:p>
             <a:fld id="{C9E664E8-8019-2444-AEBA-CE692A70D4C8}" type="datetimeFigureOut">
               <a:rPr lang="en-US" smtClean="0"/>
-              <a:t>10/2/25</a:t>
+              <a:t>10/6/25</a:t>
             </a:fld>
             <a:endParaRPr lang="en-US"/>
           </a:p>
@@ -6236,7 +6236,7 @@
           <a:p>
             <a:fld id="{C9E664E8-8019-2444-AEBA-CE692A70D4C8}" type="datetimeFigureOut">
               <a:rPr lang="en-US" smtClean="0"/>
-              <a:t>10/2/25</a:t>
+              <a:t>10/6/25</a:t>
             </a:fld>
             <a:endParaRPr lang="en-US"/>
           </a:p>
@@ -6349,7 +6349,7 @@
           <a:p>
             <a:fld id="{C9E664E8-8019-2444-AEBA-CE692A70D4C8}" type="datetimeFigureOut">
               <a:rPr lang="en-US" smtClean="0"/>
-              <a:t>10/2/25</a:t>
+              <a:t>10/6/25</a:t>
             </a:fld>
             <a:endParaRPr lang="en-US"/>
           </a:p>
@@ -6660,7 +6660,7 @@
           <a:p>
             <a:fld id="{C9E664E8-8019-2444-AEBA-CE692A70D4C8}" type="datetimeFigureOut">
               <a:rPr lang="en-US" smtClean="0"/>
-              <a:t>10/2/25</a:t>
+              <a:t>10/6/25</a:t>
             </a:fld>
             <a:endParaRPr lang="en-US"/>
           </a:p>
@@ -6948,7 +6948,7 @@
           <a:p>
             <a:fld id="{C9E664E8-8019-2444-AEBA-CE692A70D4C8}" type="datetimeFigureOut">
               <a:rPr lang="en-US" smtClean="0"/>
-              <a:t>10/2/25</a:t>
+              <a:t>10/6/25</a:t>
             </a:fld>
             <a:endParaRPr lang="en-US"/>
           </a:p>
@@ -7189,7 +7189,7 @@
           <a:p>
             <a:fld id="{C9E664E8-8019-2444-AEBA-CE692A70D4C8}" type="datetimeFigureOut">
               <a:rPr lang="en-US" smtClean="0"/>
-              <a:t>10/2/25</a:t>
+              <a:t>10/6/25</a:t>
             </a:fld>
             <a:endParaRPr lang="en-US"/>
           </a:p>
@@ -8243,7 +8243,7 @@
           <a:effectLst/>
           <a:extLst>
             <a:ext uri="{AF507438-7753-43e0-B8FC-AC1667EBCBE1}">
-              <a14:hiddenEffects xmlns="" xmlns:a14="http://schemas.microsoft.com/office/drawing/2010/main">
+              <a14:hiddenEffects xmlns:a14="http://schemas.microsoft.com/office/drawing/2010/main" xmlns="">
                 <a:effectLst>
                   <a:outerShdw blurRad="63500" dist="38099" dir="2700000" algn="ctr" rotWithShape="0">
                     <a:schemeClr val="bg2">
@@ -8320,12 +8320,12 @@
           <a:effectLst/>
           <a:extLst>
             <a:ext uri="{909E8E84-426E-40dd-AFC4-6F175D3DCCD1}">
-              <a14:hiddenFill xmlns="" xmlns:a14="http://schemas.microsoft.com/office/drawing/2010/main">
+              <a14:hiddenFill xmlns:a14="http://schemas.microsoft.com/office/drawing/2010/main" xmlns="">
                 <a:noFill/>
               </a14:hiddenFill>
             </a:ext>
             <a:ext uri="{AF507438-7753-43e0-B8FC-AC1667EBCBE1}">
-              <a14:hiddenEffects xmlns="" xmlns:a14="http://schemas.microsoft.com/office/drawing/2010/main">
+              <a14:hiddenEffects xmlns:a14="http://schemas.microsoft.com/office/drawing/2010/main" xmlns="">
                 <a:effectLst>
                   <a:outerShdw blurRad="63500" dist="38099" dir="2700000" algn="ctr" rotWithShape="0">
                     <a:schemeClr val="bg2">
@@ -8373,14 +8373,14 @@
           <a:effectLst/>
           <a:extLst>
             <a:ext uri="{909E8E84-426E-40dd-AFC4-6F175D3DCCD1}">
-              <a14:hiddenFill xmlns="" xmlns:a14="http://schemas.microsoft.com/office/drawing/2010/main">
+              <a14:hiddenFill xmlns:a14="http://schemas.microsoft.com/office/drawing/2010/main" xmlns="">
                 <a:solidFill>
                   <a:schemeClr val="accent1"/>
                 </a:solidFill>
               </a14:hiddenFill>
             </a:ext>
             <a:ext uri="{91240B29-F687-4f45-9708-019B960494DF}">
-              <a14:hiddenLine xmlns="" xmlns:a14="http://schemas.microsoft.com/office/drawing/2010/main" w="12700">
+              <a14:hiddenLine xmlns:a14="http://schemas.microsoft.com/office/drawing/2010/main" xmlns="" w="12700">
                 <a:solidFill>
                   <a:schemeClr val="tx1"/>
                 </a:solidFill>
@@ -8390,7 +8390,7 @@
               </a14:hiddenLine>
             </a:ext>
             <a:ext uri="{AF507438-7753-43e0-B8FC-AC1667EBCBE1}">
-              <a14:hiddenEffects xmlns="" xmlns:a14="http://schemas.microsoft.com/office/drawing/2010/main">
+              <a14:hiddenEffects xmlns:a14="http://schemas.microsoft.com/office/drawing/2010/main" xmlns="">
                 <a:effectLst>
                   <a:outerShdw blurRad="63500" dist="38099" dir="2700000" algn="ctr" rotWithShape="0">
                     <a:schemeClr val="bg2">
@@ -8470,14 +8470,14 @@
           <a:effectLst/>
           <a:extLst>
             <a:ext uri="{909E8E84-426E-40dd-AFC4-6F175D3DCCD1}">
-              <a14:hiddenFill xmlns="" xmlns:a14="http://schemas.microsoft.com/office/drawing/2010/main">
+              <a14:hiddenFill xmlns:a14="http://schemas.microsoft.com/office/drawing/2010/main" xmlns="">
                 <a:solidFill>
                   <a:schemeClr val="accent1"/>
                 </a:solidFill>
               </a14:hiddenFill>
             </a:ext>
             <a:ext uri="{91240B29-F687-4f45-9708-019B960494DF}">
-              <a14:hiddenLine xmlns="" xmlns:a14="http://schemas.microsoft.com/office/drawing/2010/main" w="12700">
+              <a14:hiddenLine xmlns:a14="http://schemas.microsoft.com/office/drawing/2010/main" xmlns="" w="12700">
                 <a:solidFill>
                   <a:schemeClr val="tx1"/>
                 </a:solidFill>
@@ -8487,7 +8487,7 @@
               </a14:hiddenLine>
             </a:ext>
             <a:ext uri="{AF507438-7753-43e0-B8FC-AC1667EBCBE1}">
-              <a14:hiddenEffects xmlns="" xmlns:a14="http://schemas.microsoft.com/office/drawing/2010/main">
+              <a14:hiddenEffects xmlns:a14="http://schemas.microsoft.com/office/drawing/2010/main" xmlns="">
                 <a:effectLst>
                   <a:outerShdw blurRad="63500" dist="38099" dir="2700000" algn="ctr" rotWithShape="0">
                     <a:schemeClr val="bg2">
@@ -8567,7 +8567,7 @@
           <a:effectLst/>
           <a:extLst>
             <a:ext uri="{AF507438-7753-43e0-B8FC-AC1667EBCBE1}">
-              <a14:hiddenEffects xmlns="" xmlns:a14="http://schemas.microsoft.com/office/drawing/2010/main">
+              <a14:hiddenEffects xmlns:a14="http://schemas.microsoft.com/office/drawing/2010/main" xmlns="">
                 <a:effectLst>
                   <a:outerShdw blurRad="63500" dist="38099" dir="2700000" algn="ctr" rotWithShape="0">
                     <a:schemeClr val="bg2">
@@ -8633,7 +8633,7 @@
           <a:effectLst/>
           <a:extLst>
             <a:ext uri="{AF507438-7753-43e0-B8FC-AC1667EBCBE1}">
-              <a14:hiddenEffects xmlns="" xmlns:a14="http://schemas.microsoft.com/office/drawing/2010/main">
+              <a14:hiddenEffects xmlns:a14="http://schemas.microsoft.com/office/drawing/2010/main" xmlns="">
                 <a:effectLst>
                   <a:outerShdw blurRad="63500" dist="38099" dir="2700000" algn="ctr" rotWithShape="0">
                     <a:schemeClr val="bg2">
@@ -8700,14 +8700,14 @@
           <a:effectLst/>
           <a:extLst>
             <a:ext uri="{909E8E84-426E-40dd-AFC4-6F175D3DCCD1}">
-              <a14:hiddenFill xmlns="" xmlns:a14="http://schemas.microsoft.com/office/drawing/2010/main">
+              <a14:hiddenFill xmlns:a14="http://schemas.microsoft.com/office/drawing/2010/main" xmlns="">
                 <a:solidFill>
                   <a:schemeClr val="accent1"/>
                 </a:solidFill>
               </a14:hiddenFill>
             </a:ext>
             <a:ext uri="{91240B29-F687-4f45-9708-019B960494DF}">
-              <a14:hiddenLine xmlns="" xmlns:a14="http://schemas.microsoft.com/office/drawing/2010/main" w="12700">
+              <a14:hiddenLine xmlns:a14="http://schemas.microsoft.com/office/drawing/2010/main" xmlns="" w="12700">
                 <a:solidFill>
                   <a:schemeClr val="tx1"/>
                 </a:solidFill>
@@ -8717,7 +8717,7 @@
               </a14:hiddenLine>
             </a:ext>
             <a:ext uri="{AF507438-7753-43e0-B8FC-AC1667EBCBE1}">
-              <a14:hiddenEffects xmlns="" xmlns:a14="http://schemas.microsoft.com/office/drawing/2010/main">
+              <a14:hiddenEffects xmlns:a14="http://schemas.microsoft.com/office/drawing/2010/main" xmlns="">
                 <a:effectLst>
                   <a:outerShdw blurRad="63500" dist="38099" dir="2700000" algn="ctr" rotWithShape="0">
                     <a:schemeClr val="bg2">
@@ -8791,12 +8791,12 @@
           <a:effectLst/>
           <a:extLst>
             <a:ext uri="{909E8E84-426E-40dd-AFC4-6F175D3DCCD1}">
-              <a14:hiddenFill xmlns="" xmlns:a14="http://schemas.microsoft.com/office/drawing/2010/main">
+              <a14:hiddenFill xmlns:a14="http://schemas.microsoft.com/office/drawing/2010/main" xmlns="">
                 <a:noFill/>
               </a14:hiddenFill>
             </a:ext>
             <a:ext uri="{AF507438-7753-43e0-B8FC-AC1667EBCBE1}">
-              <a14:hiddenEffects xmlns="" xmlns:a14="http://schemas.microsoft.com/office/drawing/2010/main">
+              <a14:hiddenEffects xmlns:a14="http://schemas.microsoft.com/office/drawing/2010/main" xmlns="">
                 <a:effectLst>
                   <a:outerShdw blurRad="63500" dist="38099" dir="2700000" algn="ctr" rotWithShape="0">
                     <a:schemeClr val="bg2">
@@ -8849,12 +8849,12 @@
           <a:effectLst/>
           <a:extLst>
             <a:ext uri="{909E8E84-426E-40dd-AFC4-6F175D3DCCD1}">
-              <a14:hiddenFill xmlns="" xmlns:a14="http://schemas.microsoft.com/office/drawing/2010/main">
+              <a14:hiddenFill xmlns:a14="http://schemas.microsoft.com/office/drawing/2010/main" xmlns="">
                 <a:noFill/>
               </a14:hiddenFill>
             </a:ext>
             <a:ext uri="{AF507438-7753-43e0-B8FC-AC1667EBCBE1}">
-              <a14:hiddenEffects xmlns="" xmlns:a14="http://schemas.microsoft.com/office/drawing/2010/main">
+              <a14:hiddenEffects xmlns:a14="http://schemas.microsoft.com/office/drawing/2010/main" xmlns="">
                 <a:effectLst>
                   <a:outerShdw blurRad="63500" dist="38099" dir="2700000" algn="ctr" rotWithShape="0">
                     <a:schemeClr val="bg2">
@@ -9046,7 +9046,7 @@
           <a:effectLst/>
           <a:extLst>
             <a:ext uri="{AF507438-7753-43e0-B8FC-AC1667EBCBE1}">
-              <a14:hiddenEffects xmlns="" xmlns:a14="http://schemas.microsoft.com/office/drawing/2010/main">
+              <a14:hiddenEffects xmlns:a14="http://schemas.microsoft.com/office/drawing/2010/main" xmlns="">
                 <a:effectLst>
                   <a:outerShdw blurRad="63500" dist="38099" dir="2700000" algn="ctr" rotWithShape="0">
                     <a:schemeClr val="bg2">
@@ -9126,12 +9126,12 @@
           <a:effectLst/>
           <a:extLst>
             <a:ext uri="{909E8E84-426E-40dd-AFC4-6F175D3DCCD1}">
-              <a14:hiddenFill xmlns="" xmlns:a14="http://schemas.microsoft.com/office/drawing/2010/main">
+              <a14:hiddenFill xmlns:a14="http://schemas.microsoft.com/office/drawing/2010/main" xmlns="">
                 <a:noFill/>
               </a14:hiddenFill>
             </a:ext>
             <a:ext uri="{AF507438-7753-43e0-B8FC-AC1667EBCBE1}">
-              <a14:hiddenEffects xmlns="" xmlns:a14="http://schemas.microsoft.com/office/drawing/2010/main">
+              <a14:hiddenEffects xmlns:a14="http://schemas.microsoft.com/office/drawing/2010/main" xmlns="">
                 <a:effectLst>
                   <a:outerShdw blurRad="63500" dist="38099" dir="2700000" algn="ctr" rotWithShape="0">
                     <a:schemeClr val="bg2">
@@ -9320,12 +9320,12 @@
           <a:effectLst/>
           <a:extLst>
             <a:ext uri="{909E8E84-426E-40dd-AFC4-6F175D3DCCD1}">
-              <a14:hiddenFill xmlns="" xmlns:a14="http://schemas.microsoft.com/office/drawing/2010/main">
+              <a14:hiddenFill xmlns:a14="http://schemas.microsoft.com/office/drawing/2010/main" xmlns="">
                 <a:noFill/>
               </a14:hiddenFill>
             </a:ext>
             <a:ext uri="{AF507438-7753-43e0-B8FC-AC1667EBCBE1}">
-              <a14:hiddenEffects xmlns="" xmlns:a14="http://schemas.microsoft.com/office/drawing/2010/main">
+              <a14:hiddenEffects xmlns:a14="http://schemas.microsoft.com/office/drawing/2010/main" xmlns="">
                 <a:effectLst>
                   <a:outerShdw blurRad="63500" dist="38099" dir="2700000" algn="ctr" rotWithShape="0">
                     <a:schemeClr val="bg2">
@@ -9383,7 +9383,7 @@
           <a:effectLst/>
           <a:extLst>
             <a:ext uri="{AF507438-7753-43e0-B8FC-AC1667EBCBE1}">
-              <a14:hiddenEffects xmlns="" xmlns:a14="http://schemas.microsoft.com/office/drawing/2010/main">
+              <a14:hiddenEffects xmlns:a14="http://schemas.microsoft.com/office/drawing/2010/main" xmlns="">
                 <a:effectLst>
                   <a:outerShdw blurRad="63500" dist="38099" dir="2700000" algn="ctr" rotWithShape="0">
                     <a:schemeClr val="bg2">
@@ -9452,12 +9452,12 @@
           <a:effectLst/>
           <a:extLst>
             <a:ext uri="{909E8E84-426E-40dd-AFC4-6F175D3DCCD1}">
-              <a14:hiddenFill xmlns="" xmlns:a14="http://schemas.microsoft.com/office/drawing/2010/main">
+              <a14:hiddenFill xmlns:a14="http://schemas.microsoft.com/office/drawing/2010/main" xmlns="">
                 <a:noFill/>
               </a14:hiddenFill>
             </a:ext>
             <a:ext uri="{AF507438-7753-43e0-B8FC-AC1667EBCBE1}">
-              <a14:hiddenEffects xmlns="" xmlns:a14="http://schemas.microsoft.com/office/drawing/2010/main">
+              <a14:hiddenEffects xmlns:a14="http://schemas.microsoft.com/office/drawing/2010/main" xmlns="">
                 <a:effectLst>
                   <a:outerShdw blurRad="63500" dist="38099" dir="2700000" algn="ctr" rotWithShape="0">
                     <a:schemeClr val="bg2">
@@ -9510,12 +9510,12 @@
           <a:effectLst/>
           <a:extLst>
             <a:ext uri="{909E8E84-426E-40dd-AFC4-6F175D3DCCD1}">
-              <a14:hiddenFill xmlns="" xmlns:a14="http://schemas.microsoft.com/office/drawing/2010/main">
+              <a14:hiddenFill xmlns:a14="http://schemas.microsoft.com/office/drawing/2010/main" xmlns="">
                 <a:noFill/>
               </a14:hiddenFill>
             </a:ext>
             <a:ext uri="{AF507438-7753-43e0-B8FC-AC1667EBCBE1}">
-              <a14:hiddenEffects xmlns="" xmlns:a14="http://schemas.microsoft.com/office/drawing/2010/main">
+              <a14:hiddenEffects xmlns:a14="http://schemas.microsoft.com/office/drawing/2010/main" xmlns="">
                 <a:effectLst>
                   <a:outerShdw blurRad="63500" dist="38099" dir="2700000" algn="ctr" rotWithShape="0">
                     <a:schemeClr val="bg2">
@@ -9563,14 +9563,14 @@
           <a:effectLst/>
           <a:extLst>
             <a:ext uri="{909E8E84-426E-40dd-AFC4-6F175D3DCCD1}">
-              <a14:hiddenFill xmlns="" xmlns:a14="http://schemas.microsoft.com/office/drawing/2010/main">
+              <a14:hiddenFill xmlns:a14="http://schemas.microsoft.com/office/drawing/2010/main" xmlns="">
                 <a:solidFill>
                   <a:schemeClr val="accent1"/>
                 </a:solidFill>
               </a14:hiddenFill>
             </a:ext>
             <a:ext uri="{91240B29-F687-4f45-9708-019B960494DF}">
-              <a14:hiddenLine xmlns="" xmlns:a14="http://schemas.microsoft.com/office/drawing/2010/main" w="12700">
+              <a14:hiddenLine xmlns:a14="http://schemas.microsoft.com/office/drawing/2010/main" xmlns="" w="12700">
                 <a:solidFill>
                   <a:schemeClr val="tx1"/>
                 </a:solidFill>
@@ -9580,7 +9580,7 @@
               </a14:hiddenLine>
             </a:ext>
             <a:ext uri="{AF507438-7753-43e0-B8FC-AC1667EBCBE1}">
-              <a14:hiddenEffects xmlns="" xmlns:a14="http://schemas.microsoft.com/office/drawing/2010/main">
+              <a14:hiddenEffects xmlns:a14="http://schemas.microsoft.com/office/drawing/2010/main" xmlns="">
                 <a:effectLst>
                   <a:outerShdw blurRad="63500" dist="38099" dir="2700000" algn="ctr" rotWithShape="0">
                     <a:schemeClr val="bg2">
@@ -9667,14 +9667,14 @@
           <a:effectLst/>
           <a:extLst>
             <a:ext uri="{909E8E84-426E-40dd-AFC4-6F175D3DCCD1}">
-              <a14:hiddenFill xmlns="" xmlns:a14="http://schemas.microsoft.com/office/drawing/2010/main">
+              <a14:hiddenFill xmlns:a14="http://schemas.microsoft.com/office/drawing/2010/main" xmlns="">
                 <a:solidFill>
                   <a:schemeClr val="accent1"/>
                 </a:solidFill>
               </a14:hiddenFill>
             </a:ext>
             <a:ext uri="{91240B29-F687-4f45-9708-019B960494DF}">
-              <a14:hiddenLine xmlns="" xmlns:a14="http://schemas.microsoft.com/office/drawing/2010/main" w="12700">
+              <a14:hiddenLine xmlns:a14="http://schemas.microsoft.com/office/drawing/2010/main" xmlns="" w="12700">
                 <a:solidFill>
                   <a:schemeClr val="tx1"/>
                 </a:solidFill>
@@ -9684,7 +9684,7 @@
               </a14:hiddenLine>
             </a:ext>
             <a:ext uri="{AF507438-7753-43e0-B8FC-AC1667EBCBE1}">
-              <a14:hiddenEffects xmlns="" xmlns:a14="http://schemas.microsoft.com/office/drawing/2010/main">
+              <a14:hiddenEffects xmlns:a14="http://schemas.microsoft.com/office/drawing/2010/main" xmlns="">
                 <a:effectLst>
                   <a:outerShdw blurRad="63500" dist="38099" dir="2700000" algn="ctr" rotWithShape="0">
                     <a:schemeClr val="bg2">
@@ -9747,12 +9747,12 @@
           <a:effectLst/>
           <a:extLst>
             <a:ext uri="{909E8E84-426E-40dd-AFC4-6F175D3DCCD1}">
-              <a14:hiddenFill xmlns="" xmlns:a14="http://schemas.microsoft.com/office/drawing/2010/main">
+              <a14:hiddenFill xmlns:a14="http://schemas.microsoft.com/office/drawing/2010/main" xmlns="">
                 <a:noFill/>
               </a14:hiddenFill>
             </a:ext>
             <a:ext uri="{AF507438-7753-43e0-B8FC-AC1667EBCBE1}">
-              <a14:hiddenEffects xmlns="" xmlns:a14="http://schemas.microsoft.com/office/drawing/2010/main">
+              <a14:hiddenEffects xmlns:a14="http://schemas.microsoft.com/office/drawing/2010/main" xmlns="">
                 <a:effectLst>
                   <a:outerShdw blurRad="63500" dist="38099" dir="2700000" algn="ctr" rotWithShape="0">
                     <a:schemeClr val="bg2">
@@ -9844,14 +9844,14 @@
           <a:effectLst/>
           <a:extLst>
             <a:ext uri="{909E8E84-426E-40dd-AFC4-6F175D3DCCD1}">
-              <a14:hiddenFill xmlns="" xmlns:a14="http://schemas.microsoft.com/office/drawing/2010/main">
+              <a14:hiddenFill xmlns:a14="http://schemas.microsoft.com/office/drawing/2010/main" xmlns="">
                 <a:solidFill>
                   <a:schemeClr val="accent1"/>
                 </a:solidFill>
               </a14:hiddenFill>
             </a:ext>
             <a:ext uri="{AF507438-7753-43e0-B8FC-AC1667EBCBE1}">
-              <a14:hiddenEffects xmlns="" xmlns:a14="http://schemas.microsoft.com/office/drawing/2010/main">
+              <a14:hiddenEffects xmlns:a14="http://schemas.microsoft.com/office/drawing/2010/main" xmlns="">
                 <a:effectLst>
                   <a:outerShdw blurRad="63500" dist="38099" dir="2700000" algn="ctr" rotWithShape="0">
                     <a:schemeClr val="bg2">
@@ -9899,14 +9899,14 @@
           <a:effectLst/>
           <a:extLst>
             <a:ext uri="{909E8E84-426E-40dd-AFC4-6F175D3DCCD1}">
-              <a14:hiddenFill xmlns="" xmlns:a14="http://schemas.microsoft.com/office/drawing/2010/main">
+              <a14:hiddenFill xmlns:a14="http://schemas.microsoft.com/office/drawing/2010/main" xmlns="">
                 <a:solidFill>
                   <a:schemeClr val="accent1"/>
                 </a:solidFill>
               </a14:hiddenFill>
             </a:ext>
             <a:ext uri="{91240B29-F687-4f45-9708-019B960494DF}">
-              <a14:hiddenLine xmlns="" xmlns:a14="http://schemas.microsoft.com/office/drawing/2010/main" w="12700">
+              <a14:hiddenLine xmlns:a14="http://schemas.microsoft.com/office/drawing/2010/main" xmlns="" w="12700">
                 <a:solidFill>
                   <a:schemeClr val="tx1"/>
                 </a:solidFill>
@@ -9916,7 +9916,7 @@
               </a14:hiddenLine>
             </a:ext>
             <a:ext uri="{AF507438-7753-43e0-B8FC-AC1667EBCBE1}">
-              <a14:hiddenEffects xmlns="" xmlns:a14="http://schemas.microsoft.com/office/drawing/2010/main">
+              <a14:hiddenEffects xmlns:a14="http://schemas.microsoft.com/office/drawing/2010/main" xmlns="">
                 <a:effectLst>
                   <a:outerShdw blurRad="63500" dist="38099" dir="2700000" algn="ctr" rotWithShape="0">
                     <a:schemeClr val="bg2">
@@ -9984,7 +9984,7 @@
           <a:effectLst/>
           <a:extLst>
             <a:ext uri="{AF507438-7753-43e0-B8FC-AC1667EBCBE1}">
-              <a14:hiddenEffects xmlns="" xmlns:a14="http://schemas.microsoft.com/office/drawing/2010/main">
+              <a14:hiddenEffects xmlns:a14="http://schemas.microsoft.com/office/drawing/2010/main" xmlns="">
                 <a:effectLst>
                   <a:outerShdw blurRad="63500" dist="38099" dir="2700000" algn="ctr" rotWithShape="0">
                     <a:schemeClr val="bg2">
@@ -10053,12 +10053,12 @@
           <a:effectLst/>
           <a:extLst>
             <a:ext uri="{909E8E84-426E-40dd-AFC4-6F175D3DCCD1}">
-              <a14:hiddenFill xmlns="" xmlns:a14="http://schemas.microsoft.com/office/drawing/2010/main">
+              <a14:hiddenFill xmlns:a14="http://schemas.microsoft.com/office/drawing/2010/main" xmlns="">
                 <a:noFill/>
               </a14:hiddenFill>
             </a:ext>
             <a:ext uri="{AF507438-7753-43e0-B8FC-AC1667EBCBE1}">
-              <a14:hiddenEffects xmlns="" xmlns:a14="http://schemas.microsoft.com/office/drawing/2010/main">
+              <a14:hiddenEffects xmlns:a14="http://schemas.microsoft.com/office/drawing/2010/main" xmlns="">
                 <a:effectLst>
                   <a:outerShdw blurRad="63500" dist="38099" dir="2700000" algn="ctr" rotWithShape="0">
                     <a:schemeClr val="bg2">
@@ -10111,12 +10111,12 @@
           <a:effectLst/>
           <a:extLst>
             <a:ext uri="{909E8E84-426E-40dd-AFC4-6F175D3DCCD1}">
-              <a14:hiddenFill xmlns="" xmlns:a14="http://schemas.microsoft.com/office/drawing/2010/main">
+              <a14:hiddenFill xmlns:a14="http://schemas.microsoft.com/office/drawing/2010/main" xmlns="">
                 <a:noFill/>
               </a14:hiddenFill>
             </a:ext>
             <a:ext uri="{AF507438-7753-43e0-B8FC-AC1667EBCBE1}">
-              <a14:hiddenEffects xmlns="" xmlns:a14="http://schemas.microsoft.com/office/drawing/2010/main">
+              <a14:hiddenEffects xmlns:a14="http://schemas.microsoft.com/office/drawing/2010/main" xmlns="">
                 <a:effectLst>
                   <a:outerShdw blurRad="63500" dist="38099" dir="2700000" algn="ctr" rotWithShape="0">
                     <a:schemeClr val="bg2">
@@ -10164,14 +10164,14 @@
           <a:effectLst/>
           <a:extLst>
             <a:ext uri="{909E8E84-426E-40dd-AFC4-6F175D3DCCD1}">
-              <a14:hiddenFill xmlns="" xmlns:a14="http://schemas.microsoft.com/office/drawing/2010/main">
+              <a14:hiddenFill xmlns:a14="http://schemas.microsoft.com/office/drawing/2010/main" xmlns="">
                 <a:solidFill>
                   <a:schemeClr val="accent1"/>
                 </a:solidFill>
               </a14:hiddenFill>
             </a:ext>
             <a:ext uri="{91240B29-F687-4f45-9708-019B960494DF}">
-              <a14:hiddenLine xmlns="" xmlns:a14="http://schemas.microsoft.com/office/drawing/2010/main" w="9525">
+              <a14:hiddenLine xmlns:a14="http://schemas.microsoft.com/office/drawing/2010/main" xmlns="" w="9525">
                 <a:solidFill>
                   <a:schemeClr val="tx1"/>
                 </a:solidFill>
@@ -10181,7 +10181,7 @@
               </a14:hiddenLine>
             </a:ext>
             <a:ext uri="{AF507438-7753-43e0-B8FC-AC1667EBCBE1}">
-              <a14:hiddenEffects xmlns="" xmlns:a14="http://schemas.microsoft.com/office/drawing/2010/main">
+              <a14:hiddenEffects xmlns:a14="http://schemas.microsoft.com/office/drawing/2010/main" xmlns="">
                 <a:effectLst>
                   <a:outerShdw blurRad="63500" dist="38099" dir="2700000" algn="ctr" rotWithShape="0">
                     <a:schemeClr val="bg2">
@@ -10272,12 +10272,12 @@
           <a:effectLst/>
           <a:extLst>
             <a:ext uri="{909E8E84-426E-40dd-AFC4-6F175D3DCCD1}">
-              <a14:hiddenFill xmlns="" xmlns:a14="http://schemas.microsoft.com/office/drawing/2010/main">
+              <a14:hiddenFill xmlns:a14="http://schemas.microsoft.com/office/drawing/2010/main" xmlns="">
                 <a:noFill/>
               </a14:hiddenFill>
             </a:ext>
             <a:ext uri="{AF507438-7753-43e0-B8FC-AC1667EBCBE1}">
-              <a14:hiddenEffects xmlns="" xmlns:a14="http://schemas.microsoft.com/office/drawing/2010/main">
+              <a14:hiddenEffects xmlns:a14="http://schemas.microsoft.com/office/drawing/2010/main" xmlns="">
                 <a:effectLst>
                   <a:outerShdw blurRad="63500" dist="38099" dir="2700000" algn="ctr" rotWithShape="0">
                     <a:schemeClr val="bg2">
@@ -10330,12 +10330,12 @@
           <a:effectLst/>
           <a:extLst>
             <a:ext uri="{909E8E84-426E-40dd-AFC4-6F175D3DCCD1}">
-              <a14:hiddenFill xmlns="" xmlns:a14="http://schemas.microsoft.com/office/drawing/2010/main">
+              <a14:hiddenFill xmlns:a14="http://schemas.microsoft.com/office/drawing/2010/main" xmlns="">
                 <a:noFill/>
               </a14:hiddenFill>
             </a:ext>
             <a:ext uri="{AF507438-7753-43e0-B8FC-AC1667EBCBE1}">
-              <a14:hiddenEffects xmlns="" xmlns:a14="http://schemas.microsoft.com/office/drawing/2010/main">
+              <a14:hiddenEffects xmlns:a14="http://schemas.microsoft.com/office/drawing/2010/main" xmlns="">
                 <a:effectLst>
                   <a:outerShdw blurRad="63500" dist="38099" dir="2700000" algn="ctr" rotWithShape="0">
                     <a:schemeClr val="bg2">
@@ -12739,12 +12739,12 @@
               <a:effectLst/>
               <a:extLst>
                 <a:ext uri="{909E8E84-426E-40dd-AFC4-6F175D3DCCD1}">
-                  <a14:hiddenFill xmlns:a14="http://schemas.microsoft.com/office/drawing/2010/main" xmlns="">
+                  <a14:hiddenFill xmlns="" xmlns:a14="http://schemas.microsoft.com/office/drawing/2010/main">
                     <a:noFill/>
                   </a14:hiddenFill>
                 </a:ext>
                 <a:ext uri="{AF507438-7753-43e0-B8FC-AC1667EBCBE1}">
-                  <a14:hiddenEffects xmlns:a14="http://schemas.microsoft.com/office/drawing/2010/main" xmlns="">
+                  <a14:hiddenEffects xmlns="" xmlns:a14="http://schemas.microsoft.com/office/drawing/2010/main">
                     <a:effectLst>
                       <a:outerShdw blurRad="63500" dist="38099" dir="2700000" algn="ctr" rotWithShape="0">
                         <a:schemeClr val="bg2">
@@ -12792,12 +12792,12 @@
               <a:effectLst/>
               <a:extLst>
                 <a:ext uri="{909E8E84-426E-40dd-AFC4-6F175D3DCCD1}">
-                  <a14:hiddenFill xmlns:a14="http://schemas.microsoft.com/office/drawing/2010/main" xmlns="">
+                  <a14:hiddenFill xmlns="" xmlns:a14="http://schemas.microsoft.com/office/drawing/2010/main">
                     <a:noFill/>
                   </a14:hiddenFill>
                 </a:ext>
                 <a:ext uri="{AF507438-7753-43e0-B8FC-AC1667EBCBE1}">
-                  <a14:hiddenEffects xmlns:a14="http://schemas.microsoft.com/office/drawing/2010/main" xmlns="">
+                  <a14:hiddenEffects xmlns="" xmlns:a14="http://schemas.microsoft.com/office/drawing/2010/main">
                     <a:effectLst>
                       <a:outerShdw blurRad="63500" dist="38099" dir="2700000" algn="ctr" rotWithShape="0">
                         <a:schemeClr val="bg2">
@@ -12845,12 +12845,12 @@
               <a:effectLst/>
               <a:extLst>
                 <a:ext uri="{909E8E84-426E-40dd-AFC4-6F175D3DCCD1}">
-                  <a14:hiddenFill xmlns:a14="http://schemas.microsoft.com/office/drawing/2010/main" xmlns="">
+                  <a14:hiddenFill xmlns="" xmlns:a14="http://schemas.microsoft.com/office/drawing/2010/main">
                     <a:noFill/>
                   </a14:hiddenFill>
                 </a:ext>
                 <a:ext uri="{AF507438-7753-43e0-B8FC-AC1667EBCBE1}">
-                  <a14:hiddenEffects xmlns:a14="http://schemas.microsoft.com/office/drawing/2010/main" xmlns="">
+                  <a14:hiddenEffects xmlns="" xmlns:a14="http://schemas.microsoft.com/office/drawing/2010/main">
                     <a:effectLst>
                       <a:outerShdw blurRad="63500" dist="38099" dir="2700000" algn="ctr" rotWithShape="0">
                         <a:schemeClr val="bg2">
@@ -12894,14 +12894,14 @@
             <a:effectLst/>
             <a:extLst>
               <a:ext uri="{909E8E84-426E-40dd-AFC4-6F175D3DCCD1}">
-                <a14:hiddenFill xmlns:a14="http://schemas.microsoft.com/office/drawing/2010/main" xmlns="">
+                <a14:hiddenFill xmlns="" xmlns:a14="http://schemas.microsoft.com/office/drawing/2010/main">
                   <a:solidFill>
                     <a:schemeClr val="accent1"/>
                   </a:solidFill>
                 </a14:hiddenFill>
               </a:ext>
               <a:ext uri="{91240B29-F687-4f45-9708-019B960494DF}">
-                <a14:hiddenLine xmlns:a14="http://schemas.microsoft.com/office/drawing/2010/main" xmlns="" w="9525">
+                <a14:hiddenLine xmlns="" xmlns:a14="http://schemas.microsoft.com/office/drawing/2010/main" w="9525">
                   <a:solidFill>
                     <a:schemeClr val="tx1"/>
                   </a:solidFill>
@@ -12911,7 +12911,7 @@
                 </a14:hiddenLine>
               </a:ext>
               <a:ext uri="{AF507438-7753-43e0-B8FC-AC1667EBCBE1}">
-                <a14:hiddenEffects xmlns:a14="http://schemas.microsoft.com/office/drawing/2010/main" xmlns="">
+                <a14:hiddenEffects xmlns="" xmlns:a14="http://schemas.microsoft.com/office/drawing/2010/main">
                   <a:effectLst>
                     <a:outerShdw blurRad="63500" dist="38099" dir="2700000" algn="ctr" rotWithShape="0">
                       <a:schemeClr val="bg2">
@@ -12964,14 +12964,14 @@
             <a:effectLst/>
             <a:extLst>
               <a:ext uri="{909E8E84-426E-40dd-AFC4-6F175D3DCCD1}">
-                <a14:hiddenFill xmlns:a14="http://schemas.microsoft.com/office/drawing/2010/main" xmlns="">
+                <a14:hiddenFill xmlns="" xmlns:a14="http://schemas.microsoft.com/office/drawing/2010/main">
                   <a:solidFill>
                     <a:schemeClr val="accent1"/>
                   </a:solidFill>
                 </a14:hiddenFill>
               </a:ext>
               <a:ext uri="{91240B29-F687-4f45-9708-019B960494DF}">
-                <a14:hiddenLine xmlns:a14="http://schemas.microsoft.com/office/drawing/2010/main" xmlns="" w="9525">
+                <a14:hiddenLine xmlns="" xmlns:a14="http://schemas.microsoft.com/office/drawing/2010/main" w="9525">
                   <a:solidFill>
                     <a:schemeClr val="tx1"/>
                   </a:solidFill>
@@ -12981,7 +12981,7 @@
                 </a14:hiddenLine>
               </a:ext>
               <a:ext uri="{AF507438-7753-43e0-B8FC-AC1667EBCBE1}">
-                <a14:hiddenEffects xmlns:a14="http://schemas.microsoft.com/office/drawing/2010/main" xmlns="">
+                <a14:hiddenEffects xmlns="" xmlns:a14="http://schemas.microsoft.com/office/drawing/2010/main">
                   <a:effectLst>
                     <a:outerShdw blurRad="63500" dist="38099" dir="2700000" algn="ctr" rotWithShape="0">
                       <a:schemeClr val="bg2">
@@ -13034,14 +13034,14 @@
             <a:effectLst/>
             <a:extLst>
               <a:ext uri="{909E8E84-426E-40dd-AFC4-6F175D3DCCD1}">
-                <a14:hiddenFill xmlns:a14="http://schemas.microsoft.com/office/drawing/2010/main" xmlns="">
+                <a14:hiddenFill xmlns="" xmlns:a14="http://schemas.microsoft.com/office/drawing/2010/main">
                   <a:solidFill>
                     <a:schemeClr val="accent1"/>
                   </a:solidFill>
                 </a14:hiddenFill>
               </a:ext>
               <a:ext uri="{91240B29-F687-4f45-9708-019B960494DF}">
-                <a14:hiddenLine xmlns:a14="http://schemas.microsoft.com/office/drawing/2010/main" xmlns="" w="9525">
+                <a14:hiddenLine xmlns="" xmlns:a14="http://schemas.microsoft.com/office/drawing/2010/main" w="9525">
                   <a:solidFill>
                     <a:schemeClr val="tx1"/>
                   </a:solidFill>
@@ -13051,7 +13051,7 @@
                 </a14:hiddenLine>
               </a:ext>
               <a:ext uri="{AF507438-7753-43e0-B8FC-AC1667EBCBE1}">
-                <a14:hiddenEffects xmlns:a14="http://schemas.microsoft.com/office/drawing/2010/main" xmlns="">
+                <a14:hiddenEffects xmlns="" xmlns:a14="http://schemas.microsoft.com/office/drawing/2010/main">
                   <a:effectLst>
                     <a:outerShdw blurRad="63500" dist="38099" dir="2700000" algn="ctr" rotWithShape="0">
                       <a:schemeClr val="bg2">
@@ -13104,14 +13104,14 @@
             <a:effectLst/>
             <a:extLst>
               <a:ext uri="{909E8E84-426E-40dd-AFC4-6F175D3DCCD1}">
-                <a14:hiddenFill xmlns:a14="http://schemas.microsoft.com/office/drawing/2010/main" xmlns="">
+                <a14:hiddenFill xmlns="" xmlns:a14="http://schemas.microsoft.com/office/drawing/2010/main">
                   <a:solidFill>
                     <a:schemeClr val="accent1"/>
                   </a:solidFill>
                 </a14:hiddenFill>
               </a:ext>
               <a:ext uri="{91240B29-F687-4f45-9708-019B960494DF}">
-                <a14:hiddenLine xmlns:a14="http://schemas.microsoft.com/office/drawing/2010/main" xmlns="" w="9525">
+                <a14:hiddenLine xmlns="" xmlns:a14="http://schemas.microsoft.com/office/drawing/2010/main" w="9525">
                   <a:solidFill>
                     <a:schemeClr val="tx1"/>
                   </a:solidFill>
@@ -13121,7 +13121,7 @@
                 </a14:hiddenLine>
               </a:ext>
               <a:ext uri="{AF507438-7753-43e0-B8FC-AC1667EBCBE1}">
-                <a14:hiddenEffects xmlns:a14="http://schemas.microsoft.com/office/drawing/2010/main" xmlns="">
+                <a14:hiddenEffects xmlns="" xmlns:a14="http://schemas.microsoft.com/office/drawing/2010/main">
                   <a:effectLst>
                     <a:outerShdw blurRad="63500" dist="38099" dir="2700000" algn="ctr" rotWithShape="0">
                       <a:schemeClr val="bg2">
@@ -13175,14 +13175,14 @@
           <a:effectLst/>
           <a:extLst>
             <a:ext uri="{909E8E84-426E-40dd-AFC4-6F175D3DCCD1}">
-              <a14:hiddenFill xmlns:a14="http://schemas.microsoft.com/office/drawing/2010/main" xmlns="">
+              <a14:hiddenFill xmlns="" xmlns:a14="http://schemas.microsoft.com/office/drawing/2010/main">
                 <a:solidFill>
                   <a:schemeClr val="accent1"/>
                 </a:solidFill>
               </a14:hiddenFill>
             </a:ext>
             <a:ext uri="{91240B29-F687-4f45-9708-019B960494DF}">
-              <a14:hiddenLine xmlns:a14="http://schemas.microsoft.com/office/drawing/2010/main" xmlns="" w="9525">
+              <a14:hiddenLine xmlns="" xmlns:a14="http://schemas.microsoft.com/office/drawing/2010/main" w="9525">
                 <a:solidFill>
                   <a:schemeClr val="tx1"/>
                 </a:solidFill>
@@ -13192,7 +13192,7 @@
               </a14:hiddenLine>
             </a:ext>
             <a:ext uri="{AF507438-7753-43e0-B8FC-AC1667EBCBE1}">
-              <a14:hiddenEffects xmlns:a14="http://schemas.microsoft.com/office/drawing/2010/main" xmlns="">
+              <a14:hiddenEffects xmlns="" xmlns:a14="http://schemas.microsoft.com/office/drawing/2010/main">
                 <a:effectLst>
                   <a:outerShdw blurRad="63500" dist="38099" dir="2700000" algn="ctr" rotWithShape="0">
                     <a:schemeClr val="bg2">
@@ -13253,14 +13253,14 @@
           <a:effectLst/>
           <a:extLst>
             <a:ext uri="{909E8E84-426E-40dd-AFC4-6F175D3DCCD1}">
-              <a14:hiddenFill xmlns:a14="http://schemas.microsoft.com/office/drawing/2010/main" xmlns="">
+              <a14:hiddenFill xmlns="" xmlns:a14="http://schemas.microsoft.com/office/drawing/2010/main">
                 <a:solidFill>
                   <a:schemeClr val="accent1"/>
                 </a:solidFill>
               </a14:hiddenFill>
             </a:ext>
             <a:ext uri="{91240B29-F687-4f45-9708-019B960494DF}">
-              <a14:hiddenLine xmlns:a14="http://schemas.microsoft.com/office/drawing/2010/main" xmlns="" w="9525">
+              <a14:hiddenLine xmlns="" xmlns:a14="http://schemas.microsoft.com/office/drawing/2010/main" w="9525">
                 <a:solidFill>
                   <a:schemeClr val="tx1"/>
                 </a:solidFill>
@@ -13270,7 +13270,7 @@
               </a14:hiddenLine>
             </a:ext>
             <a:ext uri="{AF507438-7753-43e0-B8FC-AC1667EBCBE1}">
-              <a14:hiddenEffects xmlns:a14="http://schemas.microsoft.com/office/drawing/2010/main" xmlns="">
+              <a14:hiddenEffects xmlns="" xmlns:a14="http://schemas.microsoft.com/office/drawing/2010/main">
                 <a:effectLst>
                   <a:outerShdw blurRad="63500" dist="38099" dir="2700000" algn="ctr" rotWithShape="0">
                     <a:schemeClr val="bg2">
@@ -13331,14 +13331,14 @@
           <a:effectLst/>
           <a:extLst>
             <a:ext uri="{909E8E84-426E-40dd-AFC4-6F175D3DCCD1}">
-              <a14:hiddenFill xmlns:a14="http://schemas.microsoft.com/office/drawing/2010/main" xmlns="">
+              <a14:hiddenFill xmlns="" xmlns:a14="http://schemas.microsoft.com/office/drawing/2010/main">
                 <a:solidFill>
                   <a:schemeClr val="accent1"/>
                 </a:solidFill>
               </a14:hiddenFill>
             </a:ext>
             <a:ext uri="{91240B29-F687-4f45-9708-019B960494DF}">
-              <a14:hiddenLine xmlns:a14="http://schemas.microsoft.com/office/drawing/2010/main" xmlns="" w="9525">
+              <a14:hiddenLine xmlns="" xmlns:a14="http://schemas.microsoft.com/office/drawing/2010/main" w="9525">
                 <a:solidFill>
                   <a:schemeClr val="tx1"/>
                 </a:solidFill>
@@ -13348,7 +13348,7 @@
               </a14:hiddenLine>
             </a:ext>
             <a:ext uri="{AF507438-7753-43e0-B8FC-AC1667EBCBE1}">
-              <a14:hiddenEffects xmlns:a14="http://schemas.microsoft.com/office/drawing/2010/main" xmlns="">
+              <a14:hiddenEffects xmlns="" xmlns:a14="http://schemas.microsoft.com/office/drawing/2010/main">
                 <a:effectLst>
                   <a:outerShdw blurRad="63500" dist="38099" dir="2700000" algn="ctr" rotWithShape="0">
                     <a:schemeClr val="bg2">
@@ -13397,14 +13397,14 @@
           <a:effectLst/>
           <a:extLst>
             <a:ext uri="{909E8E84-426E-40dd-AFC4-6F175D3DCCD1}">
-              <a14:hiddenFill xmlns:a14="http://schemas.microsoft.com/office/drawing/2010/main" xmlns="">
+              <a14:hiddenFill xmlns="" xmlns:a14="http://schemas.microsoft.com/office/drawing/2010/main">
                 <a:solidFill>
                   <a:schemeClr val="accent1"/>
                 </a:solidFill>
               </a14:hiddenFill>
             </a:ext>
             <a:ext uri="{91240B29-F687-4f45-9708-019B960494DF}">
-              <a14:hiddenLine xmlns:a14="http://schemas.microsoft.com/office/drawing/2010/main" xmlns="" w="9525">
+              <a14:hiddenLine xmlns="" xmlns:a14="http://schemas.microsoft.com/office/drawing/2010/main" w="9525">
                 <a:solidFill>
                   <a:schemeClr val="tx1"/>
                 </a:solidFill>
@@ -13414,7 +13414,7 @@
               </a14:hiddenLine>
             </a:ext>
             <a:ext uri="{AF507438-7753-43e0-B8FC-AC1667EBCBE1}">
-              <a14:hiddenEffects xmlns:a14="http://schemas.microsoft.com/office/drawing/2010/main" xmlns="">
+              <a14:hiddenEffects xmlns="" xmlns:a14="http://schemas.microsoft.com/office/drawing/2010/main">
                 <a:effectLst>
                   <a:outerShdw blurRad="63500" dist="38099" dir="2700000" algn="ctr" rotWithShape="0">
                     <a:schemeClr val="bg2">
@@ -13463,14 +13463,14 @@
           <a:effectLst/>
           <a:extLst>
             <a:ext uri="{909E8E84-426E-40dd-AFC4-6F175D3DCCD1}">
-              <a14:hiddenFill xmlns:a14="http://schemas.microsoft.com/office/drawing/2010/main" xmlns="">
+              <a14:hiddenFill xmlns="" xmlns:a14="http://schemas.microsoft.com/office/drawing/2010/main">
                 <a:solidFill>
                   <a:schemeClr val="accent1"/>
                 </a:solidFill>
               </a14:hiddenFill>
             </a:ext>
             <a:ext uri="{91240B29-F687-4f45-9708-019B960494DF}">
-              <a14:hiddenLine xmlns:a14="http://schemas.microsoft.com/office/drawing/2010/main" xmlns="" w="9525">
+              <a14:hiddenLine xmlns="" xmlns:a14="http://schemas.microsoft.com/office/drawing/2010/main" w="9525">
                 <a:solidFill>
                   <a:schemeClr val="tx1"/>
                 </a:solidFill>
@@ -13480,7 +13480,7 @@
               </a14:hiddenLine>
             </a:ext>
             <a:ext uri="{AF507438-7753-43e0-B8FC-AC1667EBCBE1}">
-              <a14:hiddenEffects xmlns:a14="http://schemas.microsoft.com/office/drawing/2010/main" xmlns="">
+              <a14:hiddenEffects xmlns="" xmlns:a14="http://schemas.microsoft.com/office/drawing/2010/main">
                 <a:effectLst>
                   <a:outerShdw blurRad="63500" dist="38099" dir="2700000" algn="ctr" rotWithShape="0">
                     <a:schemeClr val="bg2">
@@ -13529,14 +13529,14 @@
           <a:effectLst/>
           <a:extLst>
             <a:ext uri="{909E8E84-426E-40dd-AFC4-6F175D3DCCD1}">
-              <a14:hiddenFill xmlns:a14="http://schemas.microsoft.com/office/drawing/2010/main" xmlns="">
+              <a14:hiddenFill xmlns="" xmlns:a14="http://schemas.microsoft.com/office/drawing/2010/main">
                 <a:solidFill>
                   <a:schemeClr val="accent1"/>
                 </a:solidFill>
               </a14:hiddenFill>
             </a:ext>
             <a:ext uri="{91240B29-F687-4f45-9708-019B960494DF}">
-              <a14:hiddenLine xmlns:a14="http://schemas.microsoft.com/office/drawing/2010/main" xmlns="" w="9525">
+              <a14:hiddenLine xmlns="" xmlns:a14="http://schemas.microsoft.com/office/drawing/2010/main" w="9525">
                 <a:solidFill>
                   <a:schemeClr val="tx1"/>
                 </a:solidFill>
@@ -13546,7 +13546,7 @@
               </a14:hiddenLine>
             </a:ext>
             <a:ext uri="{AF507438-7753-43e0-B8FC-AC1667EBCBE1}">
-              <a14:hiddenEffects xmlns:a14="http://schemas.microsoft.com/office/drawing/2010/main" xmlns="">
+              <a14:hiddenEffects xmlns="" xmlns:a14="http://schemas.microsoft.com/office/drawing/2010/main">
                 <a:effectLst>
                   <a:outerShdw blurRad="63500" dist="38099" dir="2700000" algn="ctr" rotWithShape="0">
                     <a:schemeClr val="bg2">
@@ -13595,14 +13595,14 @@
           <a:effectLst/>
           <a:extLst>
             <a:ext uri="{909E8E84-426E-40dd-AFC4-6F175D3DCCD1}">
-              <a14:hiddenFill xmlns:a14="http://schemas.microsoft.com/office/drawing/2010/main" xmlns="">
+              <a14:hiddenFill xmlns="" xmlns:a14="http://schemas.microsoft.com/office/drawing/2010/main">
                 <a:solidFill>
                   <a:schemeClr val="accent1"/>
                 </a:solidFill>
               </a14:hiddenFill>
             </a:ext>
             <a:ext uri="{91240B29-F687-4f45-9708-019B960494DF}">
-              <a14:hiddenLine xmlns:a14="http://schemas.microsoft.com/office/drawing/2010/main" xmlns="" w="9525">
+              <a14:hiddenLine xmlns="" xmlns:a14="http://schemas.microsoft.com/office/drawing/2010/main" w="9525">
                 <a:solidFill>
                   <a:schemeClr val="tx1"/>
                 </a:solidFill>
@@ -13612,7 +13612,7 @@
               </a14:hiddenLine>
             </a:ext>
             <a:ext uri="{AF507438-7753-43e0-B8FC-AC1667EBCBE1}">
-              <a14:hiddenEffects xmlns:a14="http://schemas.microsoft.com/office/drawing/2010/main" xmlns="">
+              <a14:hiddenEffects xmlns="" xmlns:a14="http://schemas.microsoft.com/office/drawing/2010/main">
                 <a:effectLst>
                   <a:outerShdw blurRad="63500" dist="38099" dir="2700000" algn="ctr" rotWithShape="0">
                     <a:schemeClr val="bg2">
@@ -13753,7 +13753,7 @@
           <a:effectLst/>
           <a:extLst>
             <a:ext uri="{91240B29-F687-4f45-9708-019B960494DF}">
-              <a14:hiddenLine xmlns:a14="http://schemas.microsoft.com/office/drawing/2010/main" xmlns="" w="9525">
+              <a14:hiddenLine xmlns="" xmlns:a14="http://schemas.microsoft.com/office/drawing/2010/main" w="9525">
                 <a:solidFill>
                   <a:schemeClr val="tx1"/>
                 </a:solidFill>
@@ -13763,7 +13763,7 @@
               </a14:hiddenLine>
             </a:ext>
             <a:ext uri="{AF507438-7753-43e0-B8FC-AC1667EBCBE1}">
-              <a14:hiddenEffects xmlns:a14="http://schemas.microsoft.com/office/drawing/2010/main" xmlns="">
+              <a14:hiddenEffects xmlns="" xmlns:a14="http://schemas.microsoft.com/office/drawing/2010/main">
                 <a:effectLst>
                   <a:outerShdw blurRad="63500" dist="38099" dir="2700000" algn="ctr" rotWithShape="0">
                     <a:schemeClr val="bg2">
@@ -22225,14 +22225,14 @@
           </a:ln>
           <a:extLst>
             <a:ext uri="{909E8E84-426E-40dd-AFC4-6F175D3DCCD1}">
-              <a14:hiddenFill xmlns:a14="http://schemas.microsoft.com/office/drawing/2010/main" xmlns="">
+              <a14:hiddenFill xmlns="" xmlns:a14="http://schemas.microsoft.com/office/drawing/2010/main">
                 <a:solidFill>
                   <a:srgbClr val="FFFFFF"/>
                 </a:solidFill>
               </a14:hiddenFill>
             </a:ext>
             <a:ext uri="{91240B29-F687-4f45-9708-019B960494DF}">
-              <a14:hiddenLine xmlns:a14="http://schemas.microsoft.com/office/drawing/2010/main" xmlns="" w="9525">
+              <a14:hiddenLine xmlns="" xmlns:a14="http://schemas.microsoft.com/office/drawing/2010/main" w="9525">
                 <a:solidFill>
                   <a:srgbClr val="000000"/>
                 </a:solidFill>
@@ -22438,14 +22438,14 @@
           </a:ln>
           <a:extLst>
             <a:ext uri="{909E8E84-426E-40dd-AFC4-6F175D3DCCD1}">
-              <a14:hiddenFill xmlns:a14="http://schemas.microsoft.com/office/drawing/2010/main" xmlns="">
+              <a14:hiddenFill xmlns="" xmlns:a14="http://schemas.microsoft.com/office/drawing/2010/main">
                 <a:solidFill>
                   <a:srgbClr val="FFFFFF"/>
                 </a:solidFill>
               </a14:hiddenFill>
             </a:ext>
             <a:ext uri="{91240B29-F687-4f45-9708-019B960494DF}">
-              <a14:hiddenLine xmlns:a14="http://schemas.microsoft.com/office/drawing/2010/main" xmlns="" w="9525">
+              <a14:hiddenLine xmlns="" xmlns:a14="http://schemas.microsoft.com/office/drawing/2010/main" w="9525">
                 <a:solidFill>
                   <a:srgbClr val="000000"/>
                 </a:solidFill>
@@ -22620,14 +22620,14 @@
           </a:ln>
           <a:extLst>
             <a:ext uri="{909E8E84-426E-40dd-AFC4-6F175D3DCCD1}">
-              <a14:hiddenFill xmlns:a14="http://schemas.microsoft.com/office/drawing/2010/main" xmlns="">
+              <a14:hiddenFill xmlns="" xmlns:a14="http://schemas.microsoft.com/office/drawing/2010/main">
                 <a:solidFill>
                   <a:srgbClr val="FFFFFF"/>
                 </a:solidFill>
               </a14:hiddenFill>
             </a:ext>
             <a:ext uri="{91240B29-F687-4f45-9708-019B960494DF}">
-              <a14:hiddenLine xmlns:a14="http://schemas.microsoft.com/office/drawing/2010/main" xmlns="" w="9525">
+              <a14:hiddenLine xmlns="" xmlns:a14="http://schemas.microsoft.com/office/drawing/2010/main" w="9525">
                 <a:solidFill>
                   <a:srgbClr val="000000"/>
                 </a:solidFill>
@@ -22892,14 +22892,14 @@
           </a:ln>
           <a:extLst>
             <a:ext uri="{909E8E84-426E-40dd-AFC4-6F175D3DCCD1}">
-              <a14:hiddenFill xmlns:a14="http://schemas.microsoft.com/office/drawing/2010/main" xmlns="">
+              <a14:hiddenFill xmlns="" xmlns:a14="http://schemas.microsoft.com/office/drawing/2010/main">
                 <a:solidFill>
                   <a:srgbClr val="FFFFFF"/>
                 </a:solidFill>
               </a14:hiddenFill>
             </a:ext>
             <a:ext uri="{91240B29-F687-4f45-9708-019B960494DF}">
-              <a14:hiddenLine xmlns:a14="http://schemas.microsoft.com/office/drawing/2010/main" xmlns="" w="9525">
+              <a14:hiddenLine xmlns="" xmlns:a14="http://schemas.microsoft.com/office/drawing/2010/main" w="9525">
                 <a:solidFill>
                   <a:srgbClr val="000000"/>
                 </a:solidFill>
@@ -23693,7 +23693,7 @@
           <a:noFill/>
           <a:extLst>
             <a:ext uri="{909E8E84-426E-40dd-AFC4-6F175D3DCCD1}">
-              <a14:hiddenFill xmlns="" xmlns:a14="http://schemas.microsoft.com/office/drawing/2010/main">
+              <a14:hiddenFill xmlns:a14="http://schemas.microsoft.com/office/drawing/2010/main" xmlns="">
                 <a:solidFill>
                   <a:srgbClr val="FFFFFF"/>
                 </a:solidFill>
@@ -25085,14 +25085,14 @@
           </a:ln>
           <a:extLst>
             <a:ext uri="{909E8E84-426E-40dd-AFC4-6F175D3DCCD1}">
-              <a14:hiddenFill xmlns="" xmlns:a14="http://schemas.microsoft.com/office/drawing/2010/main">
+              <a14:hiddenFill xmlns:a14="http://schemas.microsoft.com/office/drawing/2010/main" xmlns="">
                 <a:solidFill>
                   <a:srgbClr val="FFFFFF"/>
                 </a:solidFill>
               </a14:hiddenFill>
             </a:ext>
             <a:ext uri="{91240B29-F687-4f45-9708-019B960494DF}">
-              <a14:hiddenLine xmlns="" xmlns:a14="http://schemas.microsoft.com/office/drawing/2010/main" w="9525">
+              <a14:hiddenLine xmlns:a14="http://schemas.microsoft.com/office/drawing/2010/main" xmlns="" w="9525">
                 <a:solidFill>
                   <a:srgbClr val="000000"/>
                 </a:solidFill>

</xml_diff>